<commit_message>
added to here page for all slides
</commit_message>
<xml_diff>
--- a/Week03_CopyingData/Ch04_CopyingData_Excercises_V4.pptx
+++ b/Week03_CopyingData/Ch04_CopyingData_Excercises_V4.pptx
@@ -8,10 +8,10 @@
     <p:sldMasterId id="2147483710" r:id="rId4"/>
   </p:sldMasterIdLst>
   <p:notesMasterIdLst>
-    <p:notesMasterId r:id="rId37"/>
+    <p:notesMasterId r:id="rId38"/>
   </p:notesMasterIdLst>
   <p:handoutMasterIdLst>
-    <p:handoutMasterId r:id="rId38"/>
+    <p:handoutMasterId r:id="rId39"/>
   </p:handoutMasterIdLst>
   <p:sldIdLst>
     <p:sldId id="333" r:id="rId5"/>
@@ -46,6 +46,7 @@
     <p:sldId id="398" r:id="rId34"/>
     <p:sldId id="399" r:id="rId35"/>
     <p:sldId id="336" r:id="rId36"/>
+    <p:sldId id="509" r:id="rId37"/>
   </p:sldIdLst>
   <p:sldSz cx="12192000" cy="6858000"/>
   <p:notesSz cx="7010400" cy="9296400"/>
@@ -234,7 +235,7 @@
           <a:p>
             <a:fld id="{8E938536-29D3-49BD-A567-41CAF057586A}" type="datetimeFigureOut">
               <a:rPr lang="en-US" smtClean="0"/>
-              <a:t>8/20/2026</a:t>
+              <a:t>9/22/2026</a:t>
             </a:fld>
             <a:endParaRPr lang="en-US"/>
           </a:p>
@@ -399,7 +400,7 @@
           <a:p>
             <a:fld id="{71559A16-B3AD-4CE2-9A5E-FAAD3C2C27CA}" type="datetimeFigureOut">
               <a:rPr lang="en-US" smtClean="0"/>
-              <a:t>8/20/2026</a:t>
+              <a:t>9/22/2026</a:t>
             </a:fld>
             <a:endParaRPr lang="en-US"/>
           </a:p>
@@ -6054,7 +6055,7 @@
                 <a:tabLst/>
                 <a:defRPr/>
               </a:pPr>
-              <a:t>8/20/2026</a:t>
+              <a:t>9/22/2026</a:t>
             </a:fld>
             <a:endParaRPr kumimoji="0" lang="en-US" sz="1800" b="0" i="0" u="none" strike="noStrike" kern="1200" cap="none" spc="0" normalizeH="0" baseline="0" noProof="0">
               <a:ln>
@@ -6451,7 +6452,7 @@
             <a:fld id="{1D8BD707-D9CF-40AE-B4C6-C98DA3205C09}" type="datetimeFigureOut">
               <a:rPr lang="en-US" smtClean="0"/>
               <a:pPr/>
-              <a:t>8/20/2026</a:t>
+              <a:t>9/22/2026</a:t>
             </a:fld>
             <a:endParaRPr lang="en-US"/>
           </a:p>
@@ -6570,7 +6571,7 @@
             <a:fld id="{1D8BD707-D9CF-40AE-B4C6-C98DA3205C09}" type="datetimeFigureOut">
               <a:rPr lang="en-US" smtClean="0"/>
               <a:pPr/>
-              <a:t>8/20/2026</a:t>
+              <a:t>9/22/2026</a:t>
             </a:fld>
             <a:endParaRPr lang="en-US"/>
           </a:p>
@@ -6972,7 +6973,7 @@
                 <a:tabLst/>
                 <a:defRPr/>
               </a:pPr>
-              <a:t>8/20/2026</a:t>
+              <a:t>9/22/2026</a:t>
             </a:fld>
             <a:endParaRPr kumimoji="0" lang="en-US" sz="1800" b="0" i="0" u="none" strike="noStrike" kern="1200" cap="none" spc="0" normalizeH="0" baseline="0" noProof="0">
               <a:ln>
@@ -32733,6 +32734,70 @@
     <p:extLst>
       <p:ext uri="{BB962C8B-B14F-4D97-AF65-F5344CB8AC3E}">
         <p14:creationId xmlns:p14="http://schemas.microsoft.com/office/powerpoint/2010/main" val="2453586173"/>
+      </p:ext>
+    </p:extLst>
+  </p:cSld>
+  <p:clrMapOvr>
+    <a:masterClrMapping/>
+  </p:clrMapOvr>
+</p:sld>
+</file>
+
+<file path=ppt/slides/slide33.xml><?xml version="1.0" encoding="utf-8"?>
+<p:sld xmlns:a="http://schemas.openxmlformats.org/drawingml/2006/main" xmlns:r="http://schemas.openxmlformats.org/officeDocument/2006/relationships" xmlns:p="http://schemas.openxmlformats.org/presentationml/2006/main">
+  <p:cSld>
+    <p:spTree>
+      <p:nvGrpSpPr>
+        <p:cNvPr id="1" name="">
+          <a:extLst>
+            <a:ext uri="{FF2B5EF4-FFF2-40B4-BE49-F238E27FC236}">
+              <a16:creationId xmlns:a16="http://schemas.microsoft.com/office/drawing/2014/main" id="{84DA25F2-3AE0-BDCF-0880-EDD5EEF55E54}"/>
+            </a:ext>
+          </a:extLst>
+        </p:cNvPr>
+        <p:cNvGrpSpPr/>
+        <p:nvPr/>
+      </p:nvGrpSpPr>
+      <p:grpSpPr>
+        <a:xfrm>
+          <a:off x="0" y="0"/>
+          <a:ext cx="0" cy="0"/>
+          <a:chOff x="0" y="0"/>
+          <a:chExt cx="0" cy="0"/>
+        </a:xfrm>
+      </p:grpSpPr>
+      <p:sp>
+        <p:nvSpPr>
+          <p:cNvPr id="2" name="Title 1">
+            <a:extLst>
+              <a:ext uri="{FF2B5EF4-FFF2-40B4-BE49-F238E27FC236}">
+                <a16:creationId xmlns:a16="http://schemas.microsoft.com/office/drawing/2014/main" id="{6EAE57A2-3A61-C5F8-EEFD-EA2961784338}"/>
+              </a:ext>
+            </a:extLst>
+          </p:cNvPr>
+          <p:cNvSpPr>
+            <a:spLocks noGrp="1"/>
+          </p:cNvSpPr>
+          <p:nvPr>
+            <p:ph type="ctrTitle"/>
+          </p:nvPr>
+        </p:nvSpPr>
+        <p:spPr/>
+        <p:txBody>
+          <a:bodyPr/>
+          <a:lstStyle/>
+          <a:p>
+            <a:r>
+              <a:rPr lang="en-US" dirty="0"/>
+              <a:t>… to here …</a:t>
+            </a:r>
+          </a:p>
+        </p:txBody>
+      </p:sp>
+    </p:spTree>
+    <p:extLst>
+      <p:ext uri="{BB962C8B-B14F-4D97-AF65-F5344CB8AC3E}">
+        <p14:creationId xmlns:p14="http://schemas.microsoft.com/office/powerpoint/2010/main" val="2815624037"/>
       </p:ext>
     </p:extLst>
   </p:cSld>

</xml_diff>